<commit_message>
fix: review follow-ups - footer contrast, overlap coverage, QA comments
</commit_message>
<xml_diff>
--- a/deck/SHB-CreditOps-EvidenceGraph-pitch.pptx
+++ b/deck/SHB-CreditOps-EvidenceGraph-pitch.pptx
@@ -4942,7 +4942,7 @@
             <a:r>
               <a:rPr sz="700" b="0" i="0">
                 <a:solidFill>
-                  <a:srgbClr val="8A8A8A"/>
+                  <a:srgbClr val="445063"/>
                 </a:solidFill>
                 <a:latin typeface="Segoe UI"/>
               </a:rPr>
@@ -5955,7 +5955,7 @@
             <a:r>
               <a:rPr sz="700" b="0" i="0">
                 <a:solidFill>
-                  <a:srgbClr val="8A8A8A"/>
+                  <a:srgbClr val="445063"/>
                 </a:solidFill>
                 <a:latin typeface="Segoe UI"/>
               </a:rPr>
@@ -6607,7 +6607,7 @@
             <a:r>
               <a:rPr sz="700" b="0" i="0">
                 <a:solidFill>
-                  <a:srgbClr val="8A8A8A"/>
+                  <a:srgbClr val="445063"/>
                 </a:solidFill>
                 <a:latin typeface="Segoe UI"/>
               </a:rPr>
@@ -7313,7 +7313,7 @@
             <a:r>
               <a:rPr sz="700" b="0" i="0">
                 <a:solidFill>
-                  <a:srgbClr val="8A8A8A"/>
+                  <a:srgbClr val="445063"/>
                 </a:solidFill>
                 <a:latin typeface="Segoe UI"/>
               </a:rPr>
@@ -7325,7 +7325,7 @@
             <a:r>
               <a:rPr sz="700" b="0" i="0">
                 <a:solidFill>
-                  <a:srgbClr val="8A8A8A"/>
+                  <a:srgbClr val="445063"/>
                 </a:solidFill>
                 <a:latin typeface="Segoe UI"/>
               </a:rPr>
@@ -7708,7 +7708,7 @@
             <a:r>
               <a:rPr sz="700" b="0" i="0">
                 <a:solidFill>
-                  <a:srgbClr val="8A8A8A"/>
+                  <a:srgbClr val="445063"/>
                 </a:solidFill>
                 <a:latin typeface="Segoe UI"/>
               </a:rPr>
@@ -7987,7 +7987,7 @@
             <a:r>
               <a:rPr sz="700" b="0" i="0">
                 <a:solidFill>
-                  <a:srgbClr val="8A8A8A"/>
+                  <a:srgbClr val="445063"/>
                 </a:solidFill>
                 <a:latin typeface="Segoe UI"/>
               </a:rPr>
@@ -8500,7 +8500,7 @@
             <a:r>
               <a:rPr sz="700" b="0" i="0">
                 <a:solidFill>
-                  <a:srgbClr val="8A8A8A"/>
+                  <a:srgbClr val="445063"/>
                 </a:solidFill>
                 <a:latin typeface="Segoe UI"/>
               </a:rPr>
@@ -9152,7 +9152,7 @@
             <a:r>
               <a:rPr sz="700" b="0" i="0">
                 <a:solidFill>
-                  <a:srgbClr val="8A8A8A"/>
+                  <a:srgbClr val="445063"/>
                 </a:solidFill>
                 <a:latin typeface="Segoe UI"/>
               </a:rPr>
@@ -9776,7 +9776,7 @@
             <a:r>
               <a:rPr sz="700" b="0" i="0">
                 <a:solidFill>
-                  <a:srgbClr val="8A8A8A"/>
+                  <a:srgbClr val="445063"/>
                 </a:solidFill>
                 <a:latin typeface="Segoe UI"/>
               </a:rPr>
@@ -10214,7 +10214,7 @@
             <a:r>
               <a:rPr sz="700" b="0" i="0">
                 <a:solidFill>
-                  <a:srgbClr val="8A8A8A"/>
+                  <a:srgbClr val="445063"/>
                 </a:solidFill>
                 <a:latin typeface="Segoe UI"/>
               </a:rPr>
@@ -10941,7 +10941,7 @@
             <a:r>
               <a:rPr sz="700" b="0" i="0">
                 <a:solidFill>
-                  <a:srgbClr val="8A8A8A"/>
+                  <a:srgbClr val="445063"/>
                 </a:solidFill>
                 <a:latin typeface="Segoe UI"/>
               </a:rPr>
@@ -10953,7 +10953,7 @@
             <a:r>
               <a:rPr sz="700" b="0" i="0">
                 <a:solidFill>
-                  <a:srgbClr val="8A8A8A"/>
+                  <a:srgbClr val="445063"/>
                 </a:solidFill>
                 <a:latin typeface="Segoe UI"/>
               </a:rPr>
@@ -11293,7 +11293,7 @@
             <a:r>
               <a:rPr sz="1100" b="0" i="0">
                 <a:solidFill>
-                  <a:srgbClr val="1A1A1A"/>
+                  <a:srgbClr val="445063"/>
                 </a:solidFill>
                 <a:latin typeface="Segoe UI"/>
               </a:rPr>
@@ -11312,7 +11312,7 @@
             <a:r>
               <a:rPr sz="1100" b="0" i="0">
                 <a:solidFill>
-                  <a:srgbClr val="1A1A1A"/>
+                  <a:srgbClr val="445063"/>
                 </a:solidFill>
                 <a:latin typeface="Segoe UI"/>
               </a:rPr>
@@ -11331,7 +11331,7 @@
             <a:r>
               <a:rPr sz="1100" b="0" i="0">
                 <a:solidFill>
-                  <a:srgbClr val="1A1A1A"/>
+                  <a:srgbClr val="445063"/>
                 </a:solidFill>
                 <a:latin typeface="Segoe UI"/>
               </a:rPr>
@@ -11350,7 +11350,7 @@
             <a:r>
               <a:rPr sz="1100" b="0" i="0">
                 <a:solidFill>
-                  <a:srgbClr val="1A1A1A"/>
+                  <a:srgbClr val="445063"/>
                 </a:solidFill>
                 <a:latin typeface="Segoe UI"/>
               </a:rPr>
@@ -11369,7 +11369,7 @@
             <a:r>
               <a:rPr sz="1100" b="0" i="0">
                 <a:solidFill>
-                  <a:srgbClr val="1A1A1A"/>
+                  <a:srgbClr val="445063"/>
                 </a:solidFill>
                 <a:latin typeface="Segoe UI"/>
               </a:rPr>
@@ -11388,7 +11388,7 @@
             <a:r>
               <a:rPr sz="1100" b="0" i="0">
                 <a:solidFill>
-                  <a:srgbClr val="1A1A1A"/>
+                  <a:srgbClr val="445063"/>
                 </a:solidFill>
                 <a:latin typeface="Segoe UI"/>
               </a:rPr>
@@ -11585,7 +11585,7 @@
             <a:r>
               <a:rPr sz="700" b="0" i="0">
                 <a:solidFill>
-                  <a:srgbClr val="8A8A8A"/>
+                  <a:srgbClr val="445063"/>
                 </a:solidFill>
                 <a:latin typeface="Segoe UI"/>
               </a:rPr>
@@ -11597,7 +11597,7 @@
             <a:r>
               <a:rPr sz="700" b="0" i="0">
                 <a:solidFill>
-                  <a:srgbClr val="8A8A8A"/>
+                  <a:srgbClr val="445063"/>
                 </a:solidFill>
                 <a:latin typeface="Segoe UI"/>
               </a:rPr>
@@ -12061,7 +12061,7 @@
             <a:r>
               <a:rPr sz="700" b="0" i="0">
                 <a:solidFill>
-                  <a:srgbClr val="8A8A8A"/>
+                  <a:srgbClr val="445063"/>
                 </a:solidFill>
                 <a:latin typeface="Segoe UI"/>
               </a:rPr>
@@ -12073,7 +12073,7 @@
             <a:r>
               <a:rPr sz="700" b="0" i="0">
                 <a:solidFill>
-                  <a:srgbClr val="8A8A8A"/>
+                  <a:srgbClr val="445063"/>
                 </a:solidFill>
                 <a:latin typeface="Segoe UI"/>
               </a:rPr>
@@ -12631,7 +12631,7 @@
             <a:r>
               <a:rPr sz="700" b="0" i="0">
                 <a:solidFill>
-                  <a:srgbClr val="8A8A8A"/>
+                  <a:srgbClr val="445063"/>
                 </a:solidFill>
                 <a:latin typeface="Segoe UI"/>
               </a:rPr>
@@ -13340,7 +13340,7 @@
             <a:r>
               <a:rPr sz="700" b="0" i="0">
                 <a:solidFill>
-                  <a:srgbClr val="8A8A8A"/>
+                  <a:srgbClr val="445063"/>
                 </a:solidFill>
                 <a:latin typeface="Segoe UI"/>
               </a:rPr>
@@ -13352,7 +13352,7 @@
             <a:r>
               <a:rPr sz="700" b="0" i="0">
                 <a:solidFill>
-                  <a:srgbClr val="8A8A8A"/>
+                  <a:srgbClr val="445063"/>
                 </a:solidFill>
                 <a:latin typeface="Segoe UI"/>
               </a:rPr>
@@ -13987,7 +13987,7 @@
             <a:r>
               <a:rPr sz="700" b="0" i="0">
                 <a:solidFill>
-                  <a:srgbClr val="8A8A8A"/>
+                  <a:srgbClr val="445063"/>
                 </a:solidFill>
                 <a:latin typeface="Segoe UI"/>
               </a:rPr>

</xml_diff>